<commit_message>
docs: update author details, student ID, and subject in final report and presentation slides
</commit_message>
<xml_diff>
--- a/final_presentation.pptx
+++ b/final_presentation.pptx
@@ -3194,8 +3194,8 @@
         </p:nvSpPr>
         <p:spPr>
           <a:xfrm>
-            <a:off x="914400" y="4572000"/>
-            <a:ext cx="10360152" cy="1371600"/>
+            <a:off x="914400" y="4389120"/>
+            <a:ext cx="10360152" cy="1828800"/>
           </a:xfrm>
           <a:prstGeom prst="rect">
             <a:avLst/>
@@ -3209,20 +3209,33 @@
           <a:lstStyle/>
           <a:p>
             <a:pPr algn="ctr">
-              <a:defRPr sz="1600">
-                <a:solidFill>
-                  <a:srgbClr val="C8C8C8"/>
+              <a:defRPr sz="1800" b="1">
+                <a:solidFill>
+                  <a:srgbClr val="E6E6E6"/>
                 </a:solidFill>
                 <a:latin typeface="Segoe UI"/>
               </a:defRPr>
             </a:pPr>
             <a:r>
-              <a:t>• Σκοπός: Ψηφιοποίηση, OCR &amp; Αυτόματη ανίχνευση deadlines</a:t>
+              <a:t>Φοιτητής: Χαράλαμπος Τσακηρίδης (ΑΜ: 3180190)</a:t>
             </a:r>
           </a:p>
           <a:p>
             <a:pPr algn="ctr">
-              <a:defRPr sz="1600" b="1">
+              <a:defRPr sz="1800" b="1">
+                <a:solidFill>
+                  <a:srgbClr val="00A8CC"/>
+                </a:solidFill>
+                <a:latin typeface="Segoe UI"/>
+              </a:defRPr>
+            </a:pPr>
+            <a:r>
+              <a:t>Μάθημα: Αλληλεπίδραση Ανθρώπου - Υπολογιστή</a:t>
+            </a:r>
+          </a:p>
+          <a:p>
+            <a:pPr algn="ctr">
+              <a:defRPr sz="1600" i="1">
                 <a:solidFill>
                   <a:srgbClr val="F77F00"/>
                 </a:solidFill>
@@ -3230,7 +3243,7 @@
               </a:defRPr>
             </a:pPr>
             <a:r>
-              <a:t>• Βασικό Σύνθημα: Snap, Save, Study — Χωρίς Άγχος.</a:t>
+              <a:t>Snap, Save, Study — Χωρίς Άγχος.</a:t>
             </a:r>
           </a:p>
         </p:txBody>

</xml_diff>